<commit_message>
Replace awards slide with leadership path, switch cover to light
Slide 6 now shows the leadership path across four levels (university,
city, Russia, international) instead of award scans. The cover and the
closing slide use a light background with the portrait on a pink panel.
Slide 2 stats drop the award count in favour of the four communities
led. Rehearsal sheet updated to match.

Co-Authored-By: Claude Opus 5.5 <noreply@anthropic.com>
Claude-Session: https://claude.ai/code/session_01B8pn6do1MX9XR5yKnT7n94
</commit_message>
<xml_diff>
--- a/studrussia-2026/Гозиев_Мухаммадазиз_Лидер_поколения.pptx
+++ b/studrussia-2026/Гозиев_Мухаммадазиз_Лидер_поколения.pptx
@@ -115,35 +115,39 @@
   <p:extLst>
     <p:ext uri="{521415D9-36F7-43E2-AB2F-B90AF26B5E84}">
       <p14:sectionLst xmlns:p14="http://schemas.microsoft.com/office/powerpoint/2010/main">
-        <p14:section name="Титул" id="{a8ccc116-114b-63bf-95eb-1a172395890e}">
+        <p14:section name="Титул" id="{5866686f-d0dc-1d44-7f76-493d8e4a29d4}">
           <p14:sldIdLst>
             <p14:sldId id="256"/>
           </p14:sldIdLst>
         </p14:section>
-        <p14:section name="О себе" id="{b96a9277-b1f6-b2a6-c2a4-6b77875c27ea}">
+        <p14:section name="О себе" id="{92bd04c3-ba8e-cbe3-bfc4-9e8177fa5601}">
           <p14:sldIdLst>
             <p14:sldId id="257"/>
           </p14:sldIdLst>
         </p14:section>
-        <p14:section name="Достижения" id="{befd7e4b-a620-f367-d318-fcd18cc6f839}">
+        <p14:section name="Достижения" id="{f2b784dd-2246-9070-e766-199957b46f12}">
           <p14:sldIdLst>
             <p14:sldId id="258"/>
             <p14:sldId id="259"/>
             <p14:sldId id="260"/>
           </p14:sldIdLst>
         </p14:section>
-        <p14:section name="Подтверждения" id="{3e811888-f79a-7ecc-5648-fc1278ce8ccd}">
+        <p14:section name="Лидерство" id="{8ef8b10e-565b-bb97-e232-b75c23448c01}">
           <p14:sldIdLst>
             <p14:sldId id="261"/>
+          </p14:sldIdLst>
+        </p14:section>
+        <p14:section name="Подтверждения" id="{478a03a3-02e5-754c-3c3d-d60d9a143ec9}">
+          <p14:sldIdLst>
             <p14:sldId id="262"/>
           </p14:sldIdLst>
         </p14:section>
-        <p14:section name="Итоги и планы" id="{48b87e19-40c4-636f-7cde-398e1b6aeaee}">
+        <p14:section name="Итоги и планы" id="{b35a220b-880b-5867-0549-80ddf56c0313}">
           <p14:sldIdLst>
             <p14:sldId id="263"/>
           </p14:sldIdLst>
         </p14:section>
-        <p14:section name="Финал" id="{764dd630-a527-ac47-f551-ade0f7b5dd76}">
+        <p14:section name="Финал" id="{fc19fc72-6df9-0d94-3cfc-089cae40a33c}">
           <p14:sldIdLst>
             <p14:sldId id="264"/>
           </p14:sldIdLst>
@@ -642,7 +646,7 @@
             <a:r>
               <a:rPr lang="en-US" dirty="0"/>
               <a:t>≈35 сек.
-Я приехал учиться в Петербург из Узбекистана и по себе знаю, как важно в первые месяцы почувствовать поддержку. Поэтому моя цель: чтобы иностранный студент быстрее становился своим. Сегодня у меня четыре руководящие роли: председатель студсовета общежития, руководитель Клуба иностранных обучающихся, руководитель сектора в Международном клубе дружбы Санкт-Петербурга и координатор узбекской молодёжи университета по назначению Генерального консульства. За год это 18 мероприятий, 6 международных форумов и 22 награды. Расскажу о трёх главных результатах.</a:t>
+Я приехал учиться в Петербург из Узбекистана и по себе знаю, как важно в первые месяцы почувствовать поддержку. Поэтому моя цель: чтобы иностранный студент быстрее становился своим. Сегодня у меня четыре руководящие роли: председатель студсовета общежития, руководитель Клуба иностранных обучающихся, руководитель сектора в Международном клубе дружбы Санкт-Петербурга и координатор узбекской молодёжи университета по назначению Генерального консульства. За год это 18 мероприятий и 6 международных форумов. Расскажу о трёх главных результатах.</a:t>
             </a:r>
             <a:endParaRPr lang="en-US" dirty="0"/>
           </a:p>
@@ -998,7 +1002,7 @@
             <a:r>
               <a:rPr lang="en-US" dirty="0"/>
               <a:t>≈20 сек.
-Результаты подтверждены наградами: за год их 22. Главные: звание «Йил координатори» от Генерального консульства Узбекистана, благодарность ректора университета, благодарственное письмо Комитета по молодёжной политике Санкт-Петербурга и номинация на премию «ЧИЖ» Молодёжного парламента.</a:t>
+Мой путь лидера: начинал с совета общежития, а сегодня возглавляю четыре сообщества и работаю на всех уровнях: в университете, в городе, на всероссийских и международных площадках. Каждый шаг давал новую роль и новую команду, и на каждом уровне я представляю не себя, а студентов, которые мне доверяют.</a:t>
             </a:r>
             <a:endParaRPr lang="en-US" dirty="0"/>
           </a:p>
@@ -1339,11 +1343,11 @@
 
 <file path=ppt/slideLayouts/slideLayout2.xml><?xml version="1.0" encoding="utf-8"?>
 <p:sldLayout xmlns:a="http://schemas.openxmlformats.org/drawingml/2006/main" xmlns:r="http://schemas.openxmlformats.org/officeDocument/2006/relationships" xmlns:p="http://schemas.openxmlformats.org/presentationml/2006/main" preserve="1">
-  <p:cSld name="DARK">
+  <p:cSld name="COVER">
     <p:bg>
       <p:bgPr>
         <a:solidFill>
-          <a:srgbClr val="141418"/>
+          <a:srgbClr val="FFFFFF"/>
         </a:solidFill>
       </p:bgPr>
     </p:bg>
@@ -1928,7 +1932,7 @@
             <a:r>
               <a:rPr lang="en-US" sz="1400" b="1" dirty="0">
                 <a:solidFill>
-                  <a:schemeClr val="bg1"/>
+                  <a:schemeClr val="tx1"/>
                 </a:solidFill>
               </a:rPr>
               <a:t>СтудRussia  ·  СЗФО 2026</a:t>
@@ -1939,7 +1943,7 @@
             <a:r>
               <a:rPr lang="en-US" sz="1400" dirty="0">
                 <a:solidFill>
-                  <a:schemeClr val="accent6"/>
+                  <a:schemeClr val="tx2"/>
                 </a:solidFill>
               </a:rPr>
               <a:t>     Первое очное испытание: презентация достижений</a:t>
@@ -2018,7 +2022,7 @@
             <a:r>
               <a:rPr lang="en-US" sz="4600" b="1" dirty="0">
                 <a:solidFill>
-                  <a:schemeClr val="bg1"/>
+                  <a:schemeClr val="tx1"/>
                 </a:solidFill>
                 <a:latin typeface="+mj-lt" pitchFamily="34" charset="0"/>
                 <a:ea typeface="+mj-lt" pitchFamily="34" charset="-122"/>
@@ -2038,7 +2042,7 @@
             <a:r>
               <a:rPr lang="en-US" sz="4600" b="1" dirty="0">
                 <a:solidFill>
-                  <a:schemeClr val="bg1"/>
+                  <a:schemeClr val="tx1"/>
                 </a:solidFill>
                 <a:latin typeface="+mj-lt" pitchFamily="34" charset="0"/>
                 <a:ea typeface="+mj-lt" pitchFamily="34" charset="-122"/>
@@ -2058,7 +2062,7 @@
             <a:r>
               <a:rPr lang="en-US" sz="4600" b="1" dirty="0">
                 <a:solidFill>
-                  <a:schemeClr val="bg1"/>
+                  <a:schemeClr val="tx1"/>
                 </a:solidFill>
                 <a:latin typeface="+mj-lt" pitchFamily="34" charset="0"/>
                 <a:ea typeface="+mj-lt" pitchFamily="34" charset="-122"/>
@@ -2100,7 +2104,7 @@
             <a:r>
               <a:rPr lang="en-US" sz="1800" dirty="0">
                 <a:solidFill>
-                  <a:schemeClr val="bg1"/>
+                  <a:schemeClr val="tx1"/>
                 </a:solidFill>
               </a:rPr>
               <a:t>Студент 5 курса лечебного факультета</a:t>
@@ -2117,7 +2121,7 @@
             <a:r>
               <a:rPr lang="en-US" sz="1500" dirty="0">
                 <a:solidFill>
-                  <a:schemeClr val="accent6"/>
+                  <a:schemeClr val="tx2"/>
                 </a:solidFill>
               </a:rPr>
               <a:t>Санкт-Петербургский государственный педиатрический медицинский университет (СПбГПМУ)</a:t>
@@ -2156,7 +2160,7 @@
             <a:r>
               <a:rPr lang="en-US" sz="1200" b="1" spc="150" kern="0" dirty="0">
                 <a:solidFill>
-                  <a:schemeClr val="accent3"/>
+                  <a:schemeClr val="accent1"/>
                 </a:solidFill>
               </a:rPr>
               <a:t>НАПРАВЛЕНИЕ</a:t>
@@ -2173,7 +2177,7 @@
             <a:r>
               <a:rPr lang="en-US" sz="1700" dirty="0">
                 <a:solidFill>
-                  <a:schemeClr val="bg1"/>
+                  <a:schemeClr val="tx1"/>
                 </a:solidFill>
               </a:rPr>
               <a:t>Студенческое самоуправление и межнациональное сотрудничество</a:t>
@@ -2181,10 +2185,32 @@
             <a:endParaRPr lang="en-US" sz="1200" dirty="0"/>
           </a:p>
         </p:txBody>
+      </p:sp>
+      <p:sp>
+        <p:nvSpPr>
+          <p:cNvPr id="7" name="portrait-panel"/>
+          <p:cNvSpPr/>
+          <p:nvPr/>
+        </p:nvSpPr>
+        <p:spPr>
+          <a:xfrm>
+            <a:off x="7498080" y="1097280"/>
+            <a:ext cx="4206240" cy="5120640"/>
+          </a:xfrm>
+          <a:prstGeom prst="roundRect">
+            <a:avLst>
+              <a:gd name="adj" fmla="val 4348"/>
+            </a:avLst>
+          </a:prstGeom>
+          <a:solidFill>
+            <a:schemeClr val="bg2"/>
+          </a:solidFill>
+          <a:ln/>
+        </p:spPr>
       </p:sp>
       <p:pic>
         <p:nvPicPr>
-          <p:cNvPr id="7" name="portrait" descr="Портрет: Гозиев Мухаммадазиз на фоне флагов России и Узбекистана">    </p:cNvPr>
+          <p:cNvPr id="8" name="portrait" descr="Портрет: Гозиев Мухаммадазиз на фоне флагов России и Узбекистана">    </p:cNvPr>
           <p:cNvPicPr>
             <a:picLocks noChangeAspect="1"/>
           </p:cNvPicPr>
@@ -2208,14 +2234,14 @@
       </p:pic>
       <p:sp>
         <p:nvSpPr>
-          <p:cNvPr id="8" name="date"/>
-          <p:cNvSpPr txBox="1"/>
-          <p:nvPr/>
-        </p:nvSpPr>
-        <p:spPr>
-          <a:xfrm>
-            <a:off x="7726680" y="5669280"/>
-            <a:ext cx="3749040" cy="320040"/>
+          <p:cNvPr id="9" name="date"/>
+          <p:cNvSpPr txBox="1"/>
+          <p:nvPr/>
+        </p:nvSpPr>
+        <p:spPr>
+          <a:xfrm>
+            <a:off x="7726680" y="5596128"/>
+            <a:ext cx="3749040" cy="365760"/>
           </a:xfrm>
           <a:prstGeom prst="rect">
             <a:avLst/>
@@ -2227,18 +2253,18 @@
           <a:bodyPr wrap="square" lIns="0" tIns="0" rIns="0" bIns="0" rtlCol="0" anchor="ctr"/>
           <a:lstStyle/>
           <a:p>
-            <a:pPr algn="r" indent="0" marL="0">
-              <a:buNone/>
-            </a:pPr>
-            <a:r>
-              <a:rPr lang="en-US" sz="1300" dirty="0">
-                <a:solidFill>
-                  <a:schemeClr val="accent6"/>
+            <a:pPr algn="ctr" indent="0" marL="0">
+              <a:buNone/>
+            </a:pPr>
+            <a:r>
+              <a:rPr lang="en-US" sz="1400" b="1" dirty="0">
+                <a:solidFill>
+                  <a:schemeClr val="accent1"/>
                 </a:solidFill>
               </a:rPr>
               <a:t>Санкт-Петербург, 24–25 октября 2026</a:t>
             </a:r>
-            <a:endParaRPr lang="en-US" sz="1300" dirty="0"/>
+            <a:endParaRPr lang="en-US" sz="1400" dirty="0"/>
           </a:p>
         </p:txBody>
       </p:sp>
@@ -2794,7 +2820,7 @@
         <p:spPr>
           <a:xfrm>
             <a:off x="3977640" y="4892040"/>
-            <a:ext cx="1779194" cy="1325880"/>
+            <a:ext cx="2433218" cy="1325880"/>
           </a:xfrm>
           <a:prstGeom prst="roundRect">
             <a:avLst>
@@ -2816,7 +2842,7 @@
         <p:spPr>
           <a:xfrm>
             <a:off x="4160520" y="5001768"/>
-            <a:ext cx="1413434" cy="566928"/>
+            <a:ext cx="2067458" cy="566928"/>
           </a:xfrm>
           <a:prstGeom prst="rect">
             <a:avLst/>
@@ -2837,7 +2863,7 @@
                   <a:schemeClr val="accent1"/>
                 </a:solidFill>
               </a:rPr>
-              <a:t>18</a:t>
+              <a:t>4</a:t>
             </a:r>
             <a:endParaRPr lang="en-US" sz="3400" dirty="0"/>
           </a:p>
@@ -2852,7 +2878,7 @@
         <p:spPr>
           <a:xfrm>
             <a:off x="4160520" y="5586984"/>
-            <a:ext cx="1413434" cy="585216"/>
+            <a:ext cx="2067458" cy="585216"/>
           </a:xfrm>
           <a:prstGeom prst="rect">
             <a:avLst/>
@@ -2873,7 +2899,7 @@
                   <a:schemeClr val="tx1"/>
                 </a:solidFill>
               </a:rPr>
-              <a:t>мероприятий организовал или помог провести</a:t>
+              <a:t>сообщества под моим руководством</a:t>
             </a:r>
             <a:endParaRPr lang="en-US" sz="1300" dirty="0"/>
           </a:p>
@@ -2887,8 +2913,8 @@
         </p:nvSpPr>
         <p:spPr>
           <a:xfrm>
-            <a:off x="5939714" y="4892040"/>
-            <a:ext cx="1779194" cy="1325880"/>
+            <a:off x="6593738" y="4892040"/>
+            <a:ext cx="2433218" cy="1325880"/>
           </a:xfrm>
           <a:prstGeom prst="roundRect">
             <a:avLst>
@@ -2909,8 +2935,8 @@
         </p:nvSpPr>
         <p:spPr>
           <a:xfrm>
-            <a:off x="6122594" y="5001768"/>
-            <a:ext cx="1413434" cy="566928"/>
+            <a:off x="6776618" y="5001768"/>
+            <a:ext cx="2067458" cy="566928"/>
           </a:xfrm>
           <a:prstGeom prst="rect">
             <a:avLst/>
@@ -2931,7 +2957,7 @@
                   <a:schemeClr val="accent1"/>
                 </a:solidFill>
               </a:rPr>
-              <a:t>6</a:t>
+              <a:t>18</a:t>
             </a:r>
             <a:endParaRPr lang="en-US" sz="3400" dirty="0"/>
           </a:p>
@@ -2945,8 +2971,8 @@
         </p:nvSpPr>
         <p:spPr>
           <a:xfrm>
-            <a:off x="6122594" y="5586984"/>
-            <a:ext cx="1413434" cy="585216"/>
+            <a:off x="6776618" y="5586984"/>
+            <a:ext cx="2067458" cy="585216"/>
           </a:xfrm>
           <a:prstGeom prst="rect">
             <a:avLst/>
@@ -2967,7 +2993,7 @@
                   <a:schemeClr val="tx1"/>
                 </a:solidFill>
               </a:rPr>
-              <a:t>международных форумов и конгрессов</a:t>
+              <a:t>мероприятий организовал или помог провести за год</a:t>
             </a:r>
             <a:endParaRPr lang="en-US" sz="1300" dirty="0"/>
           </a:p>
@@ -2981,8 +3007,8 @@
         </p:nvSpPr>
         <p:spPr>
           <a:xfrm>
-            <a:off x="7901788" y="4892040"/>
-            <a:ext cx="1779194" cy="1325880"/>
+            <a:off x="9209837" y="4892040"/>
+            <a:ext cx="2433218" cy="1325880"/>
           </a:xfrm>
           <a:prstGeom prst="roundRect">
             <a:avLst>
@@ -3003,8 +3029,8 @@
         </p:nvSpPr>
         <p:spPr>
           <a:xfrm>
-            <a:off x="8084668" y="5001768"/>
-            <a:ext cx="1413434" cy="566928"/>
+            <a:off x="9392717" y="5001768"/>
+            <a:ext cx="2067458" cy="566928"/>
           </a:xfrm>
           <a:prstGeom prst="rect">
             <a:avLst/>
@@ -3025,7 +3051,7 @@
                   <a:schemeClr val="accent1"/>
                 </a:solidFill>
               </a:rPr>
-              <a:t>22</a:t>
+              <a:t>6</a:t>
             </a:r>
             <a:endParaRPr lang="en-US" sz="3400" dirty="0"/>
           </a:p>
@@ -3039,8 +3065,8 @@
         </p:nvSpPr>
         <p:spPr>
           <a:xfrm>
-            <a:off x="8084668" y="5586984"/>
-            <a:ext cx="1413434" cy="585216"/>
+            <a:off x="9392717" y="5586984"/>
+            <a:ext cx="2067458" cy="585216"/>
           </a:xfrm>
           <a:prstGeom prst="rect">
             <a:avLst/>
@@ -3061,101 +3087,7 @@
                   <a:schemeClr val="tx1"/>
                 </a:solidFill>
               </a:rPr>
-              <a:t>награды за 2025/2026 учебный год</a:t>
-            </a:r>
-            <a:endParaRPr lang="en-US" sz="1300" dirty="0"/>
-          </a:p>
-        </p:txBody>
-      </p:sp>
-      <p:sp>
-        <p:nvSpPr>
-          <p:cNvPr id="25" name="stat4-card"/>
-          <p:cNvSpPr/>
-          <p:nvPr/>
-        </p:nvSpPr>
-        <p:spPr>
-          <a:xfrm>
-            <a:off x="9863861" y="4892040"/>
-            <a:ext cx="1779194" cy="1325880"/>
-          </a:xfrm>
-          <a:prstGeom prst="roundRect">
-            <a:avLst>
-              <a:gd name="adj" fmla="val 9655"/>
-            </a:avLst>
-          </a:prstGeom>
-          <a:solidFill>
-            <a:schemeClr val="bg2"/>
-          </a:solidFill>
-          <a:ln/>
-        </p:spPr>
-      </p:sp>
-      <p:sp>
-        <p:nvSpPr>
-          <p:cNvPr id="26" name="stat4-num"/>
-          <p:cNvSpPr txBox="1"/>
-          <p:nvPr/>
-        </p:nvSpPr>
-        <p:spPr>
-          <a:xfrm>
-            <a:off x="10046741" y="5001768"/>
-            <a:ext cx="1413434" cy="566928"/>
-          </a:xfrm>
-          <a:prstGeom prst="rect">
-            <a:avLst/>
-          </a:prstGeom>
-          <a:noFill/>
-          <a:ln/>
-        </p:spPr>
-        <p:txBody>
-          <a:bodyPr wrap="square" lIns="0" tIns="0" rIns="0" bIns="0" rtlCol="0" anchor="ctr"/>
-          <a:lstStyle/>
-          <a:p>
-            <a:pPr indent="0" marL="0">
-              <a:buNone/>
-            </a:pPr>
-            <a:r>
-              <a:rPr lang="en-US" sz="3400" b="1" dirty="0">
-                <a:solidFill>
-                  <a:schemeClr val="accent1"/>
-                </a:solidFill>
-              </a:rPr>
-              <a:t>4</a:t>
-            </a:r>
-            <a:endParaRPr lang="en-US" sz="3400" dirty="0"/>
-          </a:p>
-        </p:txBody>
-      </p:sp>
-      <p:sp>
-        <p:nvSpPr>
-          <p:cNvPr id="27" name="stat4-label"/>
-          <p:cNvSpPr txBox="1"/>
-          <p:nvPr/>
-        </p:nvSpPr>
-        <p:spPr>
-          <a:xfrm>
-            <a:off x="10046741" y="5586984"/>
-            <a:ext cx="1413434" cy="585216"/>
-          </a:xfrm>
-          <a:prstGeom prst="rect">
-            <a:avLst/>
-          </a:prstGeom>
-          <a:noFill/>
-          <a:ln/>
-        </p:spPr>
-        <p:txBody>
-          <a:bodyPr wrap="square" lIns="0" tIns="0" rIns="0" bIns="0" rtlCol="0" anchor="t"/>
-          <a:lstStyle/>
-          <a:p>
-            <a:pPr indent="0" marL="0">
-              <a:buNone/>
-            </a:pPr>
-            <a:r>
-              <a:rPr lang="en-US" sz="1300" dirty="0">
-                <a:solidFill>
-                  <a:schemeClr val="tx1"/>
-                </a:solidFill>
-              </a:rPr>
-              <a:t>уровня: вуз, город, Россия, мир</a:t>
+              <a:t>международных форумов и конгрессов</a:t>
             </a:r>
             <a:endParaRPr lang="en-US" sz="1300" dirty="0"/>
           </a:p>
@@ -5562,7 +5494,7 @@
                   <a:schemeClr val="accent1"/>
                 </a:solidFill>
               </a:rPr>
-              <a:t>ПОДТВЕРЖДЕНИЯ  ·  8 ИЗ 22 НАГРАД</a:t>
+              <a:t>О СЕБЕ КАК ЛИДЕРЕ</a:t>
             </a:r>
             <a:endParaRPr lang="en-US" sz="1300" dirty="0"/>
           </a:p>
@@ -5600,7 +5532,7 @@
                   <a:schemeClr val="tx1"/>
                 </a:solidFill>
               </a:rPr>
-              <a:t>Признание на уровне вуза, города и СНГ</a:t>
+              <a:t>Мой путь лидера: от общежития до мира</a:t>
             </a:r>
             <a:endParaRPr lang="en-US" sz="3200" dirty="0"/>
           </a:p>
@@ -5608,18 +5540,76 @@
       </p:sp>
       <p:sp>
         <p:nvSpPr>
-          <p:cNvPr id="4" name="award31-card"/>
+          <p:cNvPr id="4" name="path-statement"/>
+          <p:cNvSpPr txBox="1"/>
+          <p:nvPr/>
+        </p:nvSpPr>
+        <p:spPr>
+          <a:xfrm>
+            <a:off x="548640" y="1691640"/>
+            <a:ext cx="5120640" cy="1600200"/>
+          </a:xfrm>
+          <a:prstGeom prst="rect">
+            <a:avLst/>
+          </a:prstGeom>
+          <a:noFill/>
+          <a:ln/>
+        </p:spPr>
+        <p:txBody>
+          <a:bodyPr wrap="square" lIns="0" tIns="0" rIns="0" bIns="0" rtlCol="0" anchor="t"/>
+          <a:lstStyle/>
+          <a:p>
+            <a:pPr indent="0" marL="0">
+              <a:buNone/>
+            </a:pPr>
+            <a:r>
+              <a:rPr lang="en-US" sz="2200" b="1" dirty="0">
+                <a:solidFill>
+                  <a:schemeClr val="tx1"/>
+                </a:solidFill>
+              </a:rPr>
+              <a:t>Начинал со студсовета общежития. Сегодня возглавляю </a:t>
+            </a:r>
+            <a:pPr indent="0" marL="0">
+              <a:buNone/>
+            </a:pPr>
+            <a:r>
+              <a:rPr lang="en-US" sz="2200" b="1" dirty="0">
+                <a:solidFill>
+                  <a:schemeClr val="accent1"/>
+                </a:solidFill>
+              </a:rPr>
+              <a:t>4 сообщества</a:t>
+            </a:r>
+            <a:pPr indent="0" marL="0">
+              <a:buNone/>
+            </a:pPr>
+            <a:r>
+              <a:rPr lang="en-US" sz="2200" b="1" dirty="0">
+                <a:solidFill>
+                  <a:schemeClr val="tx1"/>
+                </a:solidFill>
+              </a:rPr>
+              <a:t> и представляю студентов на уровне города, России и мира.</a:t>
+            </a:r>
+            <a:endParaRPr lang="en-US" sz="2200" dirty="0"/>
+          </a:p>
+        </p:txBody>
+      </p:sp>
+      <p:sp>
+        <p:nvSpPr>
+          <p:cNvPr id="5" name="level1-card"/>
           <p:cNvSpPr/>
           <p:nvPr/>
         </p:nvSpPr>
         <p:spPr>
           <a:xfrm>
-            <a:off x="548640" y="1691640"/>
-            <a:ext cx="2602154" cy="2148840"/>
+            <a:off x="548640" y="4160520"/>
+            <a:ext cx="2636444" cy="2057400"/>
           </a:xfrm>
           <a:prstGeom prst="roundRect">
             <a:avLst>
-              <a:gd name="adj" fmla="val 5957"/>
+              <a:gd name="adj" fmla="val 6222"/>
             </a:avLst>
           </a:prstGeom>
           <a:solidFill>
@@ -5628,40 +5618,63 @@
           <a:ln/>
         </p:spPr>
       </p:sp>
-      <p:pic>
-        <p:nvPicPr>
-          <p:cNvPr id="5" name="award31-img" descr="Звание «Йил координатори», Генконсульство Узбекистана, 2026">    </p:cNvPr>
-          <p:cNvPicPr>
-            <a:picLocks noChangeAspect="1"/>
-          </p:cNvPicPr>
-          <p:nvPr/>
-        </p:nvPicPr>
-        <p:blipFill>
-          <a:blip r:embed="rId1"/>
-          <a:stretch>
-            <a:fillRect/>
-          </a:stretch>
-        </p:blipFill>
-        <p:spPr>
-          <a:xfrm>
-            <a:off x="934829" y="1837944"/>
-            <a:ext cx="1829775" cy="1225296"/>
-          </a:xfrm>
-          <a:prstGeom prst="rect">
-            <a:avLst/>
-          </a:prstGeom>
-        </p:spPr>
-      </p:pic>
-      <p:sp>
-        <p:nvSpPr>
-          <p:cNvPr id="6" name="award31-cap"/>
-          <p:cNvSpPr txBox="1"/>
-          <p:nvPr/>
-        </p:nvSpPr>
-        <p:spPr>
-          <a:xfrm>
-            <a:off x="713232" y="3154680"/>
-            <a:ext cx="2272970" cy="594360"/>
+      <p:sp>
+        <p:nvSpPr>
+          <p:cNvPr id="6" name="level1-label"/>
+          <p:cNvSpPr txBox="1"/>
+          <p:nvPr/>
+        </p:nvSpPr>
+        <p:spPr>
+          <a:xfrm>
+            <a:off x="749808" y="4343400"/>
+            <a:ext cx="2234108" cy="292608"/>
+          </a:xfrm>
+          <a:prstGeom prst="rect">
+            <a:avLst/>
+          </a:prstGeom>
+          <a:noFill/>
+          <a:ln/>
+        </p:spPr>
+        <p:txBody>
+          <a:bodyPr wrap="square" lIns="0" tIns="0" rIns="0" bIns="0" rtlCol="0" anchor="ctr"/>
+          <a:lstStyle/>
+          <a:p>
+            <a:pPr indent="0" marL="0">
+              <a:buNone/>
+            </a:pPr>
+            <a:r>
+              <a:rPr lang="en-US" sz="1300" b="1" spc="150" kern="0" dirty="0">
+                <a:solidFill>
+                  <a:schemeClr val="accent1"/>
+                </a:solidFill>
+              </a:rPr>
+              <a:t>01  </a:t>
+            </a:r>
+            <a:pPr indent="0" marL="0">
+              <a:buNone/>
+            </a:pPr>
+            <a:r>
+              <a:rPr lang="en-US" sz="1300" b="1" spc="150" kern="0" dirty="0">
+                <a:solidFill>
+                  <a:schemeClr val="accent1"/>
+                </a:solidFill>
+              </a:rPr>
+              <a:t>УНИВЕРСИТЕТ</a:t>
+            </a:r>
+            <a:endParaRPr lang="en-US" sz="1300" dirty="0"/>
+          </a:p>
+        </p:txBody>
+      </p:sp>
+      <p:sp>
+        <p:nvSpPr>
+          <p:cNvPr id="7" name="level1-items"/>
+          <p:cNvSpPr txBox="1"/>
+          <p:nvPr/>
+        </p:nvSpPr>
+        <p:spPr>
+          <a:xfrm>
+            <a:off x="749808" y="4764024"/>
+            <a:ext cx="2270684" cy="1307592"/>
           </a:xfrm>
           <a:prstGeom prst="rect">
             <a:avLst/>
@@ -5673,35 +5686,57 @@
           <a:bodyPr wrap="square" lIns="0" tIns="0" rIns="0" bIns="0" rtlCol="0" anchor="t"/>
           <a:lstStyle/>
           <a:p>
-            <a:pPr indent="0" marL="0">
-              <a:buNone/>
-            </a:pPr>
-            <a:r>
-              <a:rPr lang="en-US" sz="1300" dirty="0">
+            <a:pPr marL="152400" indent="-152400">
+              <a:spcAft>
+                <a:spcPts val="600"/>
+              </a:spcAft>
+              <a:buSzPct val="100000"/>
+              <a:buChar char="•"/>
+            </a:pPr>
+            <a:r>
+              <a:rPr lang="en-US" sz="1400" dirty="0">
                 <a:solidFill>
                   <a:schemeClr val="tx1"/>
                 </a:solidFill>
               </a:rPr>
-              <a:t>Звание «Йил координатори», Генконсульство Узбекистана, 2026</a:t>
-            </a:r>
-            <a:endParaRPr lang="en-US" sz="1300" dirty="0"/>
-          </a:p>
-        </p:txBody>
-      </p:sp>
-      <p:sp>
-        <p:nvSpPr>
-          <p:cNvPr id="7" name="award32-card"/>
+              <a:t>Председатель студсовета общежития №2</a:t>
+            </a:r>
+            <a:endParaRPr lang="en-US" sz="1400" dirty="0"/>
+          </a:p>
+          <a:p>
+            <a:pPr marL="152400" indent="-152400">
+              <a:spcAft>
+                <a:spcPts val="600"/>
+              </a:spcAft>
+              <a:buSzPct val="100000"/>
+              <a:buChar char="•"/>
+            </a:pPr>
+            <a:r>
+              <a:rPr lang="en-US" sz="1400" dirty="0">
+                <a:solidFill>
+                  <a:schemeClr val="tx1"/>
+                </a:solidFill>
+              </a:rPr>
+              <a:t>Руководитель Клуба иностранных обучающихся</a:t>
+            </a:r>
+            <a:endParaRPr lang="en-US" sz="1400" dirty="0"/>
+          </a:p>
+        </p:txBody>
+      </p:sp>
+      <p:sp>
+        <p:nvSpPr>
+          <p:cNvPr id="8" name="level2-card"/>
           <p:cNvSpPr/>
           <p:nvPr/>
         </p:nvSpPr>
         <p:spPr>
           <a:xfrm>
-            <a:off x="3379394" y="1691640"/>
-            <a:ext cx="2602154" cy="2148840"/>
+            <a:off x="3367964" y="3611880"/>
+            <a:ext cx="2636444" cy="2606040"/>
           </a:xfrm>
           <a:prstGeom prst="roundRect">
             <a:avLst>
-              <a:gd name="adj" fmla="val 5957"/>
+              <a:gd name="adj" fmla="val 4912"/>
             </a:avLst>
           </a:prstGeom>
           <a:solidFill>
@@ -5710,40 +5745,63 @@
           <a:ln/>
         </p:spPr>
       </p:sp>
-      <p:pic>
-        <p:nvPicPr>
-          <p:cNvPr id="8" name="award32-img" descr="Почётное звание «Гордость Родины» (Yurt faxri), СНГ">    </p:cNvPr>
-          <p:cNvPicPr>
-            <a:picLocks noChangeAspect="1"/>
-          </p:cNvPicPr>
-          <p:nvPr/>
-        </p:nvPicPr>
-        <p:blipFill>
-          <a:blip r:embed="rId2"/>
-          <a:stretch>
-            <a:fillRect/>
-          </a:stretch>
-        </p:blipFill>
-        <p:spPr>
-          <a:xfrm>
-            <a:off x="3765583" y="1837944"/>
-            <a:ext cx="1829775" cy="1225296"/>
-          </a:xfrm>
-          <a:prstGeom prst="rect">
-            <a:avLst/>
-          </a:prstGeom>
-        </p:spPr>
-      </p:pic>
-      <p:sp>
-        <p:nvSpPr>
-          <p:cNvPr id="9" name="award32-cap"/>
-          <p:cNvSpPr txBox="1"/>
-          <p:nvPr/>
-        </p:nvSpPr>
-        <p:spPr>
-          <a:xfrm>
-            <a:off x="3543986" y="3154680"/>
-            <a:ext cx="2272970" cy="594360"/>
+      <p:sp>
+        <p:nvSpPr>
+          <p:cNvPr id="9" name="level2-label"/>
+          <p:cNvSpPr txBox="1"/>
+          <p:nvPr/>
+        </p:nvSpPr>
+        <p:spPr>
+          <a:xfrm>
+            <a:off x="3569132" y="3794760"/>
+            <a:ext cx="2234108" cy="292608"/>
+          </a:xfrm>
+          <a:prstGeom prst="rect">
+            <a:avLst/>
+          </a:prstGeom>
+          <a:noFill/>
+          <a:ln/>
+        </p:spPr>
+        <p:txBody>
+          <a:bodyPr wrap="square" lIns="0" tIns="0" rIns="0" bIns="0" rtlCol="0" anchor="ctr"/>
+          <a:lstStyle/>
+          <a:p>
+            <a:pPr indent="0" marL="0">
+              <a:buNone/>
+            </a:pPr>
+            <a:r>
+              <a:rPr lang="en-US" sz="1300" b="1" spc="150" kern="0" dirty="0">
+                <a:solidFill>
+                  <a:schemeClr val="accent1"/>
+                </a:solidFill>
+              </a:rPr>
+              <a:t>02  </a:t>
+            </a:r>
+            <a:pPr indent="0" marL="0">
+              <a:buNone/>
+            </a:pPr>
+            <a:r>
+              <a:rPr lang="en-US" sz="1300" b="1" spc="150" kern="0" dirty="0">
+                <a:solidFill>
+                  <a:schemeClr val="accent1"/>
+                </a:solidFill>
+              </a:rPr>
+              <a:t>ГОРОД</a:t>
+            </a:r>
+            <a:endParaRPr lang="en-US" sz="1300" dirty="0"/>
+          </a:p>
+        </p:txBody>
+      </p:sp>
+      <p:sp>
+        <p:nvSpPr>
+          <p:cNvPr id="10" name="level2-items"/>
+          <p:cNvSpPr txBox="1"/>
+          <p:nvPr/>
+        </p:nvSpPr>
+        <p:spPr>
+          <a:xfrm>
+            <a:off x="3569132" y="4215384"/>
+            <a:ext cx="2270684" cy="1856232"/>
           </a:xfrm>
           <a:prstGeom prst="rect">
             <a:avLst/>
@@ -5755,77 +5813,140 @@
           <a:bodyPr wrap="square" lIns="0" tIns="0" rIns="0" bIns="0" rtlCol="0" anchor="t"/>
           <a:lstStyle/>
           <a:p>
-            <a:pPr indent="0" marL="0">
-              <a:buNone/>
-            </a:pPr>
-            <a:r>
-              <a:rPr lang="en-US" sz="1300" dirty="0">
+            <a:pPr marL="152400" indent="-152400">
+              <a:spcAft>
+                <a:spcPts val="600"/>
+              </a:spcAft>
+              <a:buSzPct val="100000"/>
+              <a:buChar char="•"/>
+            </a:pPr>
+            <a:r>
+              <a:rPr lang="en-US" sz="1400" dirty="0">
                 <a:solidFill>
                   <a:schemeClr val="tx1"/>
                 </a:solidFill>
               </a:rPr>
-              <a:t>Почётное звание «Гордость Родины» (Yurt faxri), СНГ</a:t>
-            </a:r>
-            <a:endParaRPr lang="en-US" sz="1300" dirty="0"/>
-          </a:p>
-        </p:txBody>
-      </p:sp>
-      <p:sp>
-        <p:nvSpPr>
-          <p:cNvPr id="10" name="award41-card"/>
+              <a:t>Руководитель сектора Международного клуба дружбы СПб</a:t>
+            </a:r>
+            <a:endParaRPr lang="en-US" sz="1400" dirty="0"/>
+          </a:p>
+          <a:p>
+            <a:pPr marL="152400" indent="-152400">
+              <a:spcAft>
+                <a:spcPts val="600"/>
+              </a:spcAft>
+              <a:buSzPct val="100000"/>
+              <a:buChar char="•"/>
+            </a:pPr>
+            <a:r>
+              <a:rPr lang="en-US" sz="1400" dirty="0">
+                <a:solidFill>
+                  <a:schemeClr val="tx1"/>
+                </a:solidFill>
+              </a:rPr>
+              <a:t>Отчёт на заседании с вице-губернатором</a:t>
+            </a:r>
+            <a:endParaRPr lang="en-US" sz="1400" dirty="0"/>
+          </a:p>
+          <a:p>
+            <a:pPr marL="152400" indent="-152400">
+              <a:spcAft>
+                <a:spcPts val="600"/>
+              </a:spcAft>
+              <a:buSzPct val="100000"/>
+              <a:buChar char="•"/>
+            </a:pPr>
+            <a:r>
+              <a:rPr lang="en-US" sz="1400" dirty="0">
+                <a:solidFill>
+                  <a:schemeClr val="tx1"/>
+                </a:solidFill>
+              </a:rPr>
+              <a:t>Визит актива в Молодёжный парламент</a:t>
+            </a:r>
+            <a:endParaRPr lang="en-US" sz="1400" dirty="0"/>
+          </a:p>
+        </p:txBody>
+      </p:sp>
+      <p:sp>
+        <p:nvSpPr>
+          <p:cNvPr id="11" name="level3-card"/>
           <p:cNvSpPr/>
           <p:nvPr/>
         </p:nvSpPr>
         <p:spPr>
           <a:xfrm>
-            <a:off x="6210148" y="1691640"/>
-            <a:ext cx="2602154" cy="2148840"/>
+            <a:off x="6187288" y="3063240"/>
+            <a:ext cx="2636444" cy="3154680"/>
           </a:xfrm>
           <a:prstGeom prst="roundRect">
             <a:avLst>
-              <a:gd name="adj" fmla="val 5957"/>
+              <a:gd name="adj" fmla="val 4856"/>
             </a:avLst>
           </a:prstGeom>
           <a:solidFill>
-            <a:schemeClr val="bg2"/>
+            <a:schemeClr val="accent3"/>
           </a:solidFill>
           <a:ln/>
         </p:spPr>
       </p:sp>
-      <p:pic>
-        <p:nvPicPr>
-          <p:cNvPr id="11" name="award41-img" descr="Благодарность ректора СПбГПМУ за студенческие инициативы">    </p:cNvPr>
-          <p:cNvPicPr>
-            <a:picLocks noChangeAspect="1"/>
-          </p:cNvPicPr>
-          <p:nvPr/>
-        </p:nvPicPr>
-        <p:blipFill>
-          <a:blip r:embed="rId3"/>
-          <a:stretch>
-            <a:fillRect/>
-          </a:stretch>
-        </p:blipFill>
-        <p:spPr>
-          <a:xfrm>
-            <a:off x="6759649" y="1837944"/>
-            <a:ext cx="1503151" cy="1225296"/>
-          </a:xfrm>
-          <a:prstGeom prst="rect">
-            <a:avLst/>
-          </a:prstGeom>
-        </p:spPr>
-      </p:pic>
-      <p:sp>
-        <p:nvSpPr>
-          <p:cNvPr id="12" name="award41-cap"/>
-          <p:cNvSpPr txBox="1"/>
-          <p:nvPr/>
-        </p:nvSpPr>
-        <p:spPr>
-          <a:xfrm>
-            <a:off x="6374740" y="3154680"/>
-            <a:ext cx="2272970" cy="594360"/>
+      <p:sp>
+        <p:nvSpPr>
+          <p:cNvPr id="12" name="level3-label"/>
+          <p:cNvSpPr txBox="1"/>
+          <p:nvPr/>
+        </p:nvSpPr>
+        <p:spPr>
+          <a:xfrm>
+            <a:off x="6388456" y="3246120"/>
+            <a:ext cx="2234108" cy="292608"/>
+          </a:xfrm>
+          <a:prstGeom prst="rect">
+            <a:avLst/>
+          </a:prstGeom>
+          <a:noFill/>
+          <a:ln/>
+        </p:spPr>
+        <p:txBody>
+          <a:bodyPr wrap="square" lIns="0" tIns="0" rIns="0" bIns="0" rtlCol="0" anchor="ctr"/>
+          <a:lstStyle/>
+          <a:p>
+            <a:pPr indent="0" marL="0">
+              <a:buNone/>
+            </a:pPr>
+            <a:r>
+              <a:rPr lang="en-US" sz="1300" b="1" spc="150" kern="0" dirty="0">
+                <a:solidFill>
+                  <a:schemeClr val="accent1"/>
+                </a:solidFill>
+              </a:rPr>
+              <a:t>03  </a:t>
+            </a:r>
+            <a:pPr indent="0" marL="0">
+              <a:buNone/>
+            </a:pPr>
+            <a:r>
+              <a:rPr lang="en-US" sz="1300" b="1" spc="150" kern="0" dirty="0">
+                <a:solidFill>
+                  <a:schemeClr val="accent1"/>
+                </a:solidFill>
+              </a:rPr>
+              <a:t>РОССИЯ</a:t>
+            </a:r>
+            <a:endParaRPr lang="en-US" sz="1300" dirty="0"/>
+          </a:p>
+        </p:txBody>
+      </p:sp>
+      <p:sp>
+        <p:nvSpPr>
+          <p:cNvPr id="13" name="level3-items"/>
+          <p:cNvSpPr txBox="1"/>
+          <p:nvPr/>
+        </p:nvSpPr>
+        <p:spPr>
+          <a:xfrm>
+            <a:off x="6388456" y="3666744"/>
+            <a:ext cx="2270684" cy="2404872"/>
           </a:xfrm>
           <a:prstGeom prst="rect">
             <a:avLst/>
@@ -5837,77 +5958,140 @@
           <a:bodyPr wrap="square" lIns="0" tIns="0" rIns="0" bIns="0" rtlCol="0" anchor="t"/>
           <a:lstStyle/>
           <a:p>
-            <a:pPr indent="0" marL="0">
-              <a:buNone/>
-            </a:pPr>
-            <a:r>
-              <a:rPr lang="en-US" sz="1300" dirty="0">
+            <a:pPr marL="152400" indent="-152400">
+              <a:spcAft>
+                <a:spcPts val="600"/>
+              </a:spcAft>
+              <a:buSzPct val="100000"/>
+              <a:buChar char="•"/>
+            </a:pPr>
+            <a:r>
+              <a:rPr lang="en-US" sz="1400" dirty="0">
                 <a:solidFill>
                   <a:schemeClr val="tx1"/>
                 </a:solidFill>
               </a:rPr>
-              <a:t>Благодарность ректора СПбГПМУ за студенческие инициативы</a:t>
-            </a:r>
-            <a:endParaRPr lang="en-US" sz="1300" dirty="0"/>
-          </a:p>
-        </p:txBody>
-      </p:sp>
-      <p:sp>
-        <p:nvSpPr>
-          <p:cNvPr id="13" name="award37-card"/>
+              <a:t>Атташе Международного фестиваля молодёжи 2026</a:t>
+            </a:r>
+            <a:endParaRPr lang="en-US" sz="1400" dirty="0"/>
+          </a:p>
+          <a:p>
+            <a:pPr marL="152400" indent="-152400">
+              <a:spcAft>
+                <a:spcPts val="600"/>
+              </a:spcAft>
+              <a:buSzPct val="100000"/>
+              <a:buChar char="•"/>
+            </a:pPr>
+            <a:r>
+              <a:rPr lang="en-US" sz="1400" dirty="0">
+                <a:solidFill>
+                  <a:schemeClr val="tx1"/>
+                </a:solidFill>
+              </a:rPr>
+              <a:t>Актив сектора на Всероссийском студенческом научном форуме</a:t>
+            </a:r>
+            <a:endParaRPr lang="en-US" sz="1400" dirty="0"/>
+          </a:p>
+          <a:p>
+            <a:pPr marL="152400" indent="-152400">
+              <a:spcAft>
+                <a:spcPts val="600"/>
+              </a:spcAft>
+              <a:buSzPct val="100000"/>
+              <a:buChar char="•"/>
+            </a:pPr>
+            <a:r>
+              <a:rPr lang="en-US" sz="1400" dirty="0">
+                <a:solidFill>
+                  <a:schemeClr val="tx1"/>
+                </a:solidFill>
+              </a:rPr>
+              <a:t>Акция «Россия: семья семей»</a:t>
+            </a:r>
+            <a:endParaRPr lang="en-US" sz="1400" dirty="0"/>
+          </a:p>
+        </p:txBody>
+      </p:sp>
+      <p:sp>
+        <p:nvSpPr>
+          <p:cNvPr id="14" name="level4-card"/>
           <p:cNvSpPr/>
           <p:nvPr/>
         </p:nvSpPr>
         <p:spPr>
           <a:xfrm>
-            <a:off x="9040901" y="1691640"/>
-            <a:ext cx="2602154" cy="2148840"/>
+            <a:off x="9006611" y="2514600"/>
+            <a:ext cx="2636444" cy="3703320"/>
           </a:xfrm>
           <a:prstGeom prst="roundRect">
             <a:avLst>
-              <a:gd name="adj" fmla="val 5957"/>
+              <a:gd name="adj" fmla="val 4856"/>
             </a:avLst>
           </a:prstGeom>
           <a:solidFill>
-            <a:schemeClr val="bg2"/>
+            <a:schemeClr val="accent1"/>
           </a:solidFill>
           <a:ln/>
         </p:spPr>
       </p:sp>
-      <p:pic>
-        <p:nvPicPr>
-          <p:cNvPr id="14" name="award37-img" descr="Благодарственное письмо Комитета по молодёжной политике СПб">    </p:cNvPr>
-          <p:cNvPicPr>
-            <a:picLocks noChangeAspect="1"/>
-          </p:cNvPicPr>
-          <p:nvPr/>
-        </p:nvPicPr>
-        <p:blipFill>
-          <a:blip r:embed="rId4"/>
-          <a:stretch>
-            <a:fillRect/>
-          </a:stretch>
-        </p:blipFill>
-        <p:spPr>
-          <a:xfrm>
-            <a:off x="9590403" y="1837944"/>
-            <a:ext cx="1503151" cy="1225296"/>
-          </a:xfrm>
-          <a:prstGeom prst="rect">
-            <a:avLst/>
-          </a:prstGeom>
-        </p:spPr>
-      </p:pic>
-      <p:sp>
-        <p:nvSpPr>
-          <p:cNvPr id="15" name="award37-cap"/>
-          <p:cNvSpPr txBox="1"/>
-          <p:nvPr/>
-        </p:nvSpPr>
-        <p:spPr>
-          <a:xfrm>
-            <a:off x="9205493" y="3154680"/>
-            <a:ext cx="2272970" cy="594360"/>
+      <p:sp>
+        <p:nvSpPr>
+          <p:cNvPr id="15" name="level4-label"/>
+          <p:cNvSpPr txBox="1"/>
+          <p:nvPr/>
+        </p:nvSpPr>
+        <p:spPr>
+          <a:xfrm>
+            <a:off x="9207779" y="2697480"/>
+            <a:ext cx="2234108" cy="292608"/>
+          </a:xfrm>
+          <a:prstGeom prst="rect">
+            <a:avLst/>
+          </a:prstGeom>
+          <a:noFill/>
+          <a:ln/>
+        </p:spPr>
+        <p:txBody>
+          <a:bodyPr wrap="square" lIns="0" tIns="0" rIns="0" bIns="0" rtlCol="0" anchor="ctr"/>
+          <a:lstStyle/>
+          <a:p>
+            <a:pPr indent="0" marL="0">
+              <a:buNone/>
+            </a:pPr>
+            <a:r>
+              <a:rPr lang="en-US" sz="1300" b="1" spc="150" kern="0" dirty="0">
+                <a:solidFill>
+                  <a:schemeClr val="bg1"/>
+                </a:solidFill>
+              </a:rPr>
+              <a:t>04  </a:t>
+            </a:r>
+            <a:pPr indent="0" marL="0">
+              <a:buNone/>
+            </a:pPr>
+            <a:r>
+              <a:rPr lang="en-US" sz="1300" b="1" spc="150" kern="0" dirty="0">
+                <a:solidFill>
+                  <a:schemeClr val="bg1"/>
+                </a:solidFill>
+              </a:rPr>
+              <a:t>МЕЖДУНАРОДНЫЙ</a:t>
+            </a:r>
+            <a:endParaRPr lang="en-US" sz="1300" dirty="0"/>
+          </a:p>
+        </p:txBody>
+      </p:sp>
+      <p:sp>
+        <p:nvSpPr>
+          <p:cNvPr id="16" name="level4-items"/>
+          <p:cNvSpPr txBox="1"/>
+          <p:nvPr/>
+        </p:nvSpPr>
+        <p:spPr>
+          <a:xfrm>
+            <a:off x="9207779" y="3118104"/>
+            <a:ext cx="2270684" cy="2953512"/>
           </a:xfrm>
           <a:prstGeom prst="rect">
             <a:avLst/>
@@ -5919,346 +6103,76 @@
           <a:bodyPr wrap="square" lIns="0" tIns="0" rIns="0" bIns="0" rtlCol="0" anchor="t"/>
           <a:lstStyle/>
           <a:p>
-            <a:pPr indent="0" marL="0">
-              <a:buNone/>
-            </a:pPr>
-            <a:r>
-              <a:rPr lang="en-US" sz="1300" dirty="0">
-                <a:solidFill>
-                  <a:schemeClr val="tx1"/>
-                </a:solidFill>
-              </a:rPr>
-              <a:t>Благодарственное письмо Комитета по молодёжной политике СПб</a:t>
-            </a:r>
-            <a:endParaRPr lang="en-US" sz="1300" dirty="0"/>
-          </a:p>
-        </p:txBody>
-      </p:sp>
-      <p:sp>
-        <p:nvSpPr>
-          <p:cNvPr id="16" name="award38-card"/>
-          <p:cNvSpPr/>
-          <p:nvPr/>
-        </p:nvSpPr>
-        <p:spPr>
-          <a:xfrm>
-            <a:off x="548640" y="4041648"/>
-            <a:ext cx="2602154" cy="2148840"/>
-          </a:xfrm>
-          <a:prstGeom prst="roundRect">
-            <a:avLst>
-              <a:gd name="adj" fmla="val 5957"/>
-            </a:avLst>
-          </a:prstGeom>
-          <a:solidFill>
-            <a:schemeClr val="bg2"/>
-          </a:solidFill>
-          <a:ln/>
-        </p:spPr>
-      </p:sp>
-      <p:pic>
-        <p:nvPicPr>
-          <p:cNvPr id="17" name="award38-img" descr="Благодарность Международного клуба дружбы СПб, 2025">    </p:cNvPr>
-          <p:cNvPicPr>
-            <a:picLocks noChangeAspect="1"/>
-          </p:cNvPicPr>
-          <p:nvPr/>
-        </p:nvPicPr>
-        <p:blipFill>
-          <a:blip r:embed="rId5"/>
-          <a:stretch>
-            <a:fillRect/>
-          </a:stretch>
-        </p:blipFill>
-        <p:spPr>
-          <a:xfrm>
-            <a:off x="1098141" y="4187952"/>
-            <a:ext cx="1503151" cy="1225296"/>
-          </a:xfrm>
-          <a:prstGeom prst="rect">
-            <a:avLst/>
-          </a:prstGeom>
-        </p:spPr>
-      </p:pic>
-      <p:sp>
-        <p:nvSpPr>
-          <p:cNvPr id="18" name="award38-cap"/>
-          <p:cNvSpPr txBox="1"/>
-          <p:nvPr/>
-        </p:nvSpPr>
-        <p:spPr>
-          <a:xfrm>
-            <a:off x="713232" y="5504688"/>
-            <a:ext cx="2272970" cy="594360"/>
-          </a:xfrm>
-          <a:prstGeom prst="rect">
-            <a:avLst/>
-          </a:prstGeom>
-          <a:noFill/>
-          <a:ln/>
-        </p:spPr>
-        <p:txBody>
-          <a:bodyPr wrap="square" lIns="0" tIns="0" rIns="0" bIns="0" rtlCol="0" anchor="t"/>
-          <a:lstStyle/>
-          <a:p>
-            <a:pPr indent="0" marL="0">
-              <a:buNone/>
-            </a:pPr>
-            <a:r>
-              <a:rPr lang="en-US" sz="1300" dirty="0">
-                <a:solidFill>
-                  <a:schemeClr val="tx1"/>
-                </a:solidFill>
-              </a:rPr>
-              <a:t>Благодарность Международного клуба дружбы СПб, 2025</a:t>
-            </a:r>
-            <a:endParaRPr lang="en-US" sz="1300" dirty="0"/>
-          </a:p>
-        </p:txBody>
-      </p:sp>
-      <p:sp>
-        <p:nvSpPr>
-          <p:cNvPr id="19" name="award39-card"/>
-          <p:cNvSpPr/>
-          <p:nvPr/>
-        </p:nvSpPr>
-        <p:spPr>
-          <a:xfrm>
-            <a:off x="3379394" y="4041648"/>
-            <a:ext cx="2602154" cy="2148840"/>
-          </a:xfrm>
-          <a:prstGeom prst="roundRect">
-            <a:avLst>
-              <a:gd name="adj" fmla="val 5957"/>
-            </a:avLst>
-          </a:prstGeom>
-          <a:solidFill>
-            <a:schemeClr val="bg2"/>
-          </a:solidFill>
-          <a:ln/>
-        </p:spPr>
-      </p:sp>
-      <p:pic>
-        <p:nvPicPr>
-          <p:cNvPr id="20" name="award39-img" descr="Номинант премии «ЧИЖ» Молодёжного парламента при ЗакС">    </p:cNvPr>
-          <p:cNvPicPr>
-            <a:picLocks noChangeAspect="1"/>
-          </p:cNvPicPr>
-          <p:nvPr/>
-        </p:nvPicPr>
-        <p:blipFill>
-          <a:blip r:embed="rId6"/>
-          <a:stretch>
-            <a:fillRect/>
-          </a:stretch>
-        </p:blipFill>
-        <p:spPr>
-          <a:xfrm>
-            <a:off x="3928895" y="4187952"/>
-            <a:ext cx="1503151" cy="1225296"/>
-          </a:xfrm>
-          <a:prstGeom prst="rect">
-            <a:avLst/>
-          </a:prstGeom>
-        </p:spPr>
-      </p:pic>
-      <p:sp>
-        <p:nvSpPr>
-          <p:cNvPr id="21" name="award39-cap"/>
-          <p:cNvSpPr txBox="1"/>
-          <p:nvPr/>
-        </p:nvSpPr>
-        <p:spPr>
-          <a:xfrm>
-            <a:off x="3543986" y="5504688"/>
-            <a:ext cx="2272970" cy="594360"/>
-          </a:xfrm>
-          <a:prstGeom prst="rect">
-            <a:avLst/>
-          </a:prstGeom>
-          <a:noFill/>
-          <a:ln/>
-        </p:spPr>
-        <p:txBody>
-          <a:bodyPr wrap="square" lIns="0" tIns="0" rIns="0" bIns="0" rtlCol="0" anchor="t"/>
-          <a:lstStyle/>
-          <a:p>
-            <a:pPr indent="0" marL="0">
-              <a:buNone/>
-            </a:pPr>
-            <a:r>
-              <a:rPr lang="en-US" sz="1300" dirty="0">
-                <a:solidFill>
-                  <a:schemeClr val="tx1"/>
-                </a:solidFill>
-              </a:rPr>
-              <a:t>Номинант премии «ЧИЖ» Молодёжного парламента при ЗакС</a:t>
-            </a:r>
-            <a:endParaRPr lang="en-US" sz="1300" dirty="0"/>
-          </a:p>
-        </p:txBody>
-      </p:sp>
-      <p:sp>
-        <p:nvSpPr>
-          <p:cNvPr id="22" name="award45-card"/>
-          <p:cNvSpPr/>
-          <p:nvPr/>
-        </p:nvSpPr>
-        <p:spPr>
-          <a:xfrm>
-            <a:off x="6210148" y="4041648"/>
-            <a:ext cx="2602154" cy="2148840"/>
-          </a:xfrm>
-          <a:prstGeom prst="roundRect">
-            <a:avLst>
-              <a:gd name="adj" fmla="val 5957"/>
-            </a:avLst>
-          </a:prstGeom>
-          <a:solidFill>
-            <a:schemeClr val="bg2"/>
-          </a:solidFill>
-          <a:ln/>
-        </p:spPr>
-      </p:sp>
-      <p:pic>
-        <p:nvPicPr>
-          <p:cNvPr id="23" name="award45-img" descr="Сертификат Международного фестиваля молодёжи 2026">    </p:cNvPr>
-          <p:cNvPicPr>
-            <a:picLocks noChangeAspect="1"/>
-          </p:cNvPicPr>
-          <p:nvPr/>
-        </p:nvPicPr>
-        <p:blipFill>
-          <a:blip r:embed="rId7"/>
-          <a:stretch>
-            <a:fillRect/>
-          </a:stretch>
-        </p:blipFill>
-        <p:spPr>
-          <a:xfrm>
-            <a:off x="6759649" y="4187952"/>
-            <a:ext cx="1503151" cy="1225296"/>
-          </a:xfrm>
-          <a:prstGeom prst="rect">
-            <a:avLst/>
-          </a:prstGeom>
-        </p:spPr>
-      </p:pic>
-      <p:sp>
-        <p:nvSpPr>
-          <p:cNvPr id="24" name="award45-cap"/>
-          <p:cNvSpPr txBox="1"/>
-          <p:nvPr/>
-        </p:nvSpPr>
-        <p:spPr>
-          <a:xfrm>
-            <a:off x="6374740" y="5504688"/>
-            <a:ext cx="2272970" cy="594360"/>
-          </a:xfrm>
-          <a:prstGeom prst="rect">
-            <a:avLst/>
-          </a:prstGeom>
-          <a:noFill/>
-          <a:ln/>
-        </p:spPr>
-        <p:txBody>
-          <a:bodyPr wrap="square" lIns="0" tIns="0" rIns="0" bIns="0" rtlCol="0" anchor="t"/>
-          <a:lstStyle/>
-          <a:p>
-            <a:pPr indent="0" marL="0">
-              <a:buNone/>
-            </a:pPr>
-            <a:r>
-              <a:rPr lang="en-US" sz="1300" dirty="0">
-                <a:solidFill>
-                  <a:schemeClr val="tx1"/>
-                </a:solidFill>
-              </a:rPr>
-              <a:t>Сертификат Международного фестиваля молодёжи 2026</a:t>
-            </a:r>
-            <a:endParaRPr lang="en-US" sz="1300" dirty="0"/>
-          </a:p>
-        </p:txBody>
-      </p:sp>
-      <p:sp>
-        <p:nvSpPr>
-          <p:cNvPr id="25" name="award42-card"/>
-          <p:cNvSpPr/>
-          <p:nvPr/>
-        </p:nvSpPr>
-        <p:spPr>
-          <a:xfrm>
-            <a:off x="9040901" y="4041648"/>
-            <a:ext cx="2602154" cy="2148840"/>
-          </a:xfrm>
-          <a:prstGeom prst="roundRect">
-            <a:avLst>
-              <a:gd name="adj" fmla="val 5957"/>
-            </a:avLst>
-          </a:prstGeom>
-          <a:solidFill>
-            <a:schemeClr val="bg2"/>
-          </a:solidFill>
-          <a:ln/>
-        </p:spPr>
-      </p:sp>
-      <p:pic>
-        <p:nvPicPr>
-          <p:cNvPr id="26" name="award42-img" descr="Диплом конкурса «ОБЩАГА» СЗФО, команда СПбГПМУ">    </p:cNvPr>
-          <p:cNvPicPr>
-            <a:picLocks noChangeAspect="1"/>
-          </p:cNvPicPr>
-          <p:nvPr/>
-        </p:nvPicPr>
-        <p:blipFill>
-          <a:blip r:embed="rId8"/>
-          <a:stretch>
-            <a:fillRect/>
-          </a:stretch>
-        </p:blipFill>
-        <p:spPr>
-          <a:xfrm>
-            <a:off x="9590403" y="4187952"/>
-            <a:ext cx="1503151" cy="1225296"/>
-          </a:xfrm>
-          <a:prstGeom prst="rect">
-            <a:avLst/>
-          </a:prstGeom>
-        </p:spPr>
-      </p:pic>
-      <p:sp>
-        <p:nvSpPr>
-          <p:cNvPr id="27" name="award42-cap"/>
-          <p:cNvSpPr txBox="1"/>
-          <p:nvPr/>
-        </p:nvSpPr>
-        <p:spPr>
-          <a:xfrm>
-            <a:off x="9205493" y="5504688"/>
-            <a:ext cx="2272970" cy="594360"/>
-          </a:xfrm>
-          <a:prstGeom prst="rect">
-            <a:avLst/>
-          </a:prstGeom>
-          <a:noFill/>
-          <a:ln/>
-        </p:spPr>
-        <p:txBody>
-          <a:bodyPr wrap="square" lIns="0" tIns="0" rIns="0" bIns="0" rtlCol="0" anchor="t"/>
-          <a:lstStyle/>
-          <a:p>
-            <a:pPr indent="0" marL="0">
-              <a:buNone/>
-            </a:pPr>
-            <a:r>
-              <a:rPr lang="en-US" sz="1300" dirty="0">
-                <a:solidFill>
-                  <a:schemeClr val="tx1"/>
-                </a:solidFill>
-              </a:rPr>
-              <a:t>Диплом конкурса «ОБЩАГА» СЗФО, команда СПбГПМУ</a:t>
-            </a:r>
-            <a:endParaRPr lang="en-US" sz="1300" dirty="0"/>
+            <a:pPr marL="152400" indent="-152400">
+              <a:spcAft>
+                <a:spcPts val="600"/>
+              </a:spcAft>
+              <a:buSzPct val="100000"/>
+              <a:buChar char="•"/>
+            </a:pPr>
+            <a:r>
+              <a:rPr lang="en-US" sz="1400" dirty="0">
+                <a:solidFill>
+                  <a:schemeClr val="bg1"/>
+                </a:solidFill>
+              </a:rPr>
+              <a:t>Координатор узбекской молодёжи по назначению Генконсульства</a:t>
+            </a:r>
+            <a:endParaRPr lang="en-US" sz="1400" dirty="0"/>
+          </a:p>
+          <a:p>
+            <a:pPr marL="152400" indent="-152400">
+              <a:spcAft>
+                <a:spcPts val="600"/>
+              </a:spcAft>
+              <a:buSzPct val="100000"/>
+              <a:buChar char="•"/>
+            </a:pPr>
+            <a:r>
+              <a:rPr lang="en-US" sz="1400" dirty="0">
+                <a:solidFill>
+                  <a:schemeClr val="bg1"/>
+                </a:solidFill>
+              </a:rPr>
+              <a:t>Приём делегации Бухарского медицинского института</a:t>
+            </a:r>
+            <a:endParaRPr lang="en-US" sz="1400" dirty="0"/>
+          </a:p>
+          <a:p>
+            <a:pPr marL="152400" indent="-152400">
+              <a:spcAft>
+                <a:spcPts val="600"/>
+              </a:spcAft>
+              <a:buSzPct val="100000"/>
+              <a:buChar char="•"/>
+            </a:pPr>
+            <a:r>
+              <a:rPr lang="en-US" sz="1400" dirty="0">
+                <a:solidFill>
+                  <a:schemeClr val="bg1"/>
+                </a:solidFill>
+              </a:rPr>
+              <a:t>«Евразия Global», ПМЭФ 2026</a:t>
+            </a:r>
+            <a:endParaRPr lang="en-US" sz="1400" dirty="0"/>
+          </a:p>
+          <a:p>
+            <a:pPr marL="152400" indent="-152400">
+              <a:spcAft>
+                <a:spcPts val="600"/>
+              </a:spcAft>
+              <a:buSzPct val="100000"/>
+              <a:buChar char="•"/>
+            </a:pPr>
+            <a:r>
+              <a:rPr lang="en-US" sz="1400" dirty="0">
+                <a:solidFill>
+                  <a:schemeClr val="bg1"/>
+                </a:solidFill>
+              </a:rPr>
+              <a:t>Конгресс СНГ «Интеллектуальный код Содружества»</a:t>
+            </a:r>
+            <a:endParaRPr lang="en-US" sz="1400" dirty="0"/>
           </a:p>
         </p:txBody>
       </p:sp>
@@ -8229,7 +8143,7 @@
             <a:r>
               <a:rPr lang="en-US" sz="4800" b="1" dirty="0">
                 <a:solidFill>
-                  <a:schemeClr val="bg1"/>
+                  <a:schemeClr val="tx1"/>
                 </a:solidFill>
                 <a:latin typeface="+mj-lt" pitchFamily="34" charset="0"/>
                 <a:ea typeface="+mj-lt" pitchFamily="34" charset="-122"/>
@@ -8249,7 +8163,7 @@
             <a:r>
               <a:rPr lang="en-US" sz="4800" b="1" dirty="0">
                 <a:solidFill>
-                  <a:schemeClr val="bg1"/>
+                  <a:schemeClr val="tx1"/>
                 </a:solidFill>
                 <a:latin typeface="+mj-lt" pitchFamily="34" charset="0"/>
                 <a:ea typeface="+mj-lt" pitchFamily="34" charset="-122"/>
@@ -8288,7 +8202,7 @@
             <a:r>
               <a:rPr lang="en-US" sz="2000" i="1" dirty="0">
                 <a:solidFill>
-                  <a:schemeClr val="accent3"/>
+                  <a:schemeClr val="accent1"/>
                 </a:solidFill>
               </a:rPr>
               <a:t>«Хочу, чтобы иностранный студент в нашем университете с первых дней чувствовал себя своим»</a:t>
@@ -8327,7 +8241,7 @@
             <a:r>
               <a:rPr lang="en-US" sz="2000" b="1" dirty="0">
                 <a:solidFill>
-                  <a:schemeClr val="bg1"/>
+                  <a:schemeClr val="tx1"/>
                 </a:solidFill>
               </a:rPr>
               <a:t>Гозиев Мухаммадазиз Кодир угли</a:t>
@@ -8344,7 +8258,7 @@
             <a:r>
               <a:rPr lang="en-US" sz="1500" dirty="0">
                 <a:solidFill>
-                  <a:schemeClr val="accent6"/>
+                  <a:schemeClr val="tx2"/>
                 </a:solidFill>
               </a:rPr>
               <a:t>СПбГПМУ, лечебный факультет, 5 курс</a:t>
@@ -8361,7 +8275,7 @@
             <a:r>
               <a:rPr lang="en-US" sz="1500" dirty="0">
                 <a:solidFill>
-                  <a:schemeClr val="accent6"/>
+                  <a:schemeClr val="tx2"/>
                 </a:solidFill>
               </a:rPr>
               <a:t>Номинация «Лидер поколения»  ·  СтудRussia, СЗФО 2026</a:t>
@@ -8410,9 +8324,31 @@
           </a:p>
         </p:txBody>
       </p:sp>
+      <p:sp>
+        <p:nvSpPr>
+          <p:cNvPr id="6" name="portrait-panel"/>
+          <p:cNvSpPr/>
+          <p:nvPr/>
+        </p:nvSpPr>
+        <p:spPr>
+          <a:xfrm>
+            <a:off x="7909560" y="960120"/>
+            <a:ext cx="3749040" cy="4069080"/>
+          </a:xfrm>
+          <a:prstGeom prst="roundRect">
+            <a:avLst>
+              <a:gd name="adj" fmla="val 4878"/>
+            </a:avLst>
+          </a:prstGeom>
+          <a:solidFill>
+            <a:schemeClr val="bg2"/>
+          </a:solidFill>
+          <a:ln/>
+        </p:spPr>
+      </p:sp>
       <p:pic>
         <p:nvPicPr>
-          <p:cNvPr id="6" name="portrait-end" descr="Портрет: Гозиев Мухаммадазиз">    </p:cNvPr>
+          <p:cNvPr id="7" name="portrait-end" descr="Портрет: Гозиев Мухаммадазиз">    </p:cNvPr>
           <p:cNvPicPr>
             <a:picLocks noChangeAspect="1"/>
           </p:cNvPicPr>

</xml_diff>